<commit_message>
feat: updated PPT v1.2.0 — OpenRouter, all 15 fixes, live URLs on slide 20
</commit_message>
<xml_diff>
--- a/SafeInbox_AI_Presentation.pptx
+++ b/SafeInbox_AI_Presentation.pptx
@@ -25,6 +25,7 @@
     <p:sldId id="273" r:id="rId24"/>
     <p:sldId id="274" r:id="rId25"/>
     <p:sldId id="275" r:id="rId26"/>
+    <p:sldId id="276" r:id="rId27"/>
   </p:sldIdLst>
   <p:sldSz cx="12188952" cy="6858000" type="screen4x3"/>
   <p:notesSz cx="6858000" cy="9144000"/>
@@ -15666,8 +15667,8 @@
         </p:nvSpPr>
         <p:spPr>
           <a:xfrm>
-            <a:off x="0" y="6748272"/>
-            <a:ext cx="12188952" cy="109728"/>
+            <a:off x="0" y="6812280"/>
+            <a:ext cx="12188952" cy="45720"/>
           </a:xfrm>
           <a:prstGeom prst="rect">
             <a:avLst/>
@@ -15703,36 +15704,44 @@
       </p:sp>
       <p:sp>
         <p:nvSpPr>
-          <p:cNvPr id="4" name="TextBox 3"/>
-          <p:cNvSpPr txBox="1"/>
-          <p:nvPr/>
-        </p:nvSpPr>
-        <p:spPr>
-          <a:xfrm>
-            <a:off x="5029200" y="640080"/>
-            <a:ext cx="2103120" cy="1920240"/>
-          </a:xfrm>
-          <a:prstGeom prst="rect">
-            <a:avLst/>
-          </a:prstGeom>
-          <a:noFill/>
-        </p:spPr>
-        <p:txBody>
-          <a:bodyPr wrap="square">
-            <a:spAutoFit/>
-          </a:bodyPr>
-          <a:lstStyle/>
-          <a:p>
-            <a:pPr algn="ctr"/>
-            <a:r>
-              <a:rPr sz="9000" b="0" i="0">
-                <a:solidFill>
-                  <a:srgbClr val="6366F1"/>
-                </a:solidFill>
-                <a:latin typeface="Segoe UI"/>
-              </a:rPr>
-              <a:t>🛡</a:t>
-            </a:r>
+          <p:cNvPr id="4" name="Rectangle 3"/>
+          <p:cNvSpPr/>
+          <p:nvPr/>
+        </p:nvSpPr>
+        <p:spPr>
+          <a:xfrm>
+            <a:off x="0" y="109728"/>
+            <a:ext cx="12188952" cy="1078992"/>
+          </a:xfrm>
+          <a:prstGeom prst="rect">
+            <a:avLst/>
+          </a:prstGeom>
+          <a:solidFill>
+            <a:srgbClr val="1A1F4B"/>
+          </a:solidFill>
+          <a:ln>
+            <a:noFill/>
+          </a:ln>
+        </p:spPr>
+        <p:style>
+          <a:lnRef idx="1">
+            <a:schemeClr val="accent1"/>
+          </a:lnRef>
+          <a:fillRef idx="3">
+            <a:schemeClr val="accent1"/>
+          </a:fillRef>
+          <a:effectRef idx="2">
+            <a:schemeClr val="accent1"/>
+          </a:effectRef>
+          <a:fontRef idx="minor">
+            <a:schemeClr val="lt1"/>
+          </a:fontRef>
+        </p:style>
+        <p:txBody>
+          <a:bodyPr rtlCol="0" anchor="ctr"/>
+          <a:lstStyle/>
+          <a:p>
+            <a:pPr algn="ctr"/>
           </a:p>
         </p:txBody>
       </p:sp>
@@ -15744,29 +15753,29 @@
         </p:nvSpPr>
         <p:spPr>
           <a:xfrm>
-            <a:off x="914400" y="2606040"/>
-            <a:ext cx="10332720" cy="1143000"/>
-          </a:xfrm>
-          <a:prstGeom prst="rect">
-            <a:avLst/>
-          </a:prstGeom>
-          <a:noFill/>
-        </p:spPr>
-        <p:txBody>
-          <a:bodyPr wrap="square">
-            <a:spAutoFit/>
-          </a:bodyPr>
-          <a:lstStyle/>
-          <a:p>
-            <a:pPr algn="ctr"/>
-            <a:r>
-              <a:rPr sz="6200" b="1" i="0">
+            <a:off x="365760" y="164592"/>
+            <a:ext cx="822960" cy="822960"/>
+          </a:xfrm>
+          <a:prstGeom prst="rect">
+            <a:avLst/>
+          </a:prstGeom>
+          <a:noFill/>
+        </p:spPr>
+        <p:txBody>
+          <a:bodyPr wrap="square">
+            <a:spAutoFit/>
+          </a:bodyPr>
+          <a:lstStyle/>
+          <a:p>
+            <a:pPr algn="l"/>
+            <a:r>
+              <a:rPr sz="4600" b="0" i="0">
                 <a:solidFill>
                   <a:srgbClr val="FFFFFF"/>
                 </a:solidFill>
                 <a:latin typeface="Segoe UI"/>
               </a:rPr>
-              <a:t>Thank You</a:t>
+              <a:t>🤖</a:t>
             </a:r>
           </a:p>
         </p:txBody>
@@ -15779,43 +15788,121 @@
         </p:nvSpPr>
         <p:spPr>
           <a:xfrm>
-            <a:off x="914400" y="3730752"/>
-            <a:ext cx="10332720" cy="594360"/>
-          </a:xfrm>
-          <a:prstGeom prst="rect">
-            <a:avLst/>
-          </a:prstGeom>
-          <a:noFill/>
-        </p:spPr>
-        <p:txBody>
-          <a:bodyPr wrap="square">
-            <a:spAutoFit/>
-          </a:bodyPr>
-          <a:lstStyle/>
-          <a:p>
-            <a:pPr algn="ctr"/>
-            <a:r>
-              <a:rPr sz="2500" b="0" i="0">
+            <a:off x="1234440" y="182880"/>
+            <a:ext cx="9601200" cy="566928"/>
+          </a:xfrm>
+          <a:prstGeom prst="rect">
+            <a:avLst/>
+          </a:prstGeom>
+          <a:noFill/>
+        </p:spPr>
+        <p:txBody>
+          <a:bodyPr wrap="square">
+            <a:spAutoFit/>
+          </a:bodyPr>
+          <a:lstStyle/>
+          <a:p>
+            <a:pPr algn="l"/>
+            <a:r>
+              <a:rPr sz="2600" b="1" i="0">
+                <a:solidFill>
+                  <a:srgbClr val="FFFFFF"/>
+                </a:solidFill>
+                <a:latin typeface="Segoe UI"/>
+              </a:rPr>
+              <a:t>How IBM Bob (Kiro AI) Built SafeInbox AI</a:t>
+            </a:r>
+          </a:p>
+        </p:txBody>
+      </p:sp>
+      <p:sp>
+        <p:nvSpPr>
+          <p:cNvPr id="7" name="TextBox 6"/>
+          <p:cNvSpPr txBox="1"/>
+          <p:nvPr/>
+        </p:nvSpPr>
+        <p:spPr>
+          <a:xfrm>
+            <a:off x="1234440" y="749808"/>
+            <a:ext cx="9601200" cy="347472"/>
+          </a:xfrm>
+          <a:prstGeom prst="rect">
+            <a:avLst/>
+          </a:prstGeom>
+          <a:noFill/>
+        </p:spPr>
+        <p:txBody>
+          <a:bodyPr wrap="square">
+            <a:spAutoFit/>
+          </a:bodyPr>
+          <a:lstStyle/>
+          <a:p>
+            <a:pPr algn="l"/>
+            <a:r>
+              <a:rPr sz="1400" b="0" i="0">
                 <a:solidFill>
                   <a:srgbClr val="38BDF8"/>
                 </a:solidFill>
                 <a:latin typeface="Segoe UI"/>
               </a:rPr>
-              <a:t>Questions &amp; Discussion</a:t>
-            </a:r>
-          </a:p>
-        </p:txBody>
-      </p:sp>
-      <p:sp>
-        <p:nvSpPr>
-          <p:cNvPr id="7" name="Rectangle 6"/>
+              <a:t>IBM Bob was the primary AI development partner — architecture to deployment</a:t>
+            </a:r>
+          </a:p>
+        </p:txBody>
+      </p:sp>
+      <p:sp>
+        <p:nvSpPr>
+          <p:cNvPr id="8" name="Rectangle 7"/>
           <p:cNvSpPr/>
           <p:nvPr/>
         </p:nvSpPr>
         <p:spPr>
           <a:xfrm>
-            <a:off x="4114800" y="4434840"/>
-            <a:ext cx="3931920" cy="45720"/>
+            <a:off x="320040" y="1353312"/>
+            <a:ext cx="3822191" cy="2212848"/>
+          </a:xfrm>
+          <a:prstGeom prst="rect">
+            <a:avLst/>
+          </a:prstGeom>
+          <a:solidFill>
+            <a:srgbClr val="1E293B"/>
+          </a:solidFill>
+          <a:ln>
+            <a:noFill/>
+          </a:ln>
+        </p:spPr>
+        <p:style>
+          <a:lnRef idx="1">
+            <a:schemeClr val="accent1"/>
+          </a:lnRef>
+          <a:fillRef idx="3">
+            <a:schemeClr val="accent1"/>
+          </a:fillRef>
+          <a:effectRef idx="2">
+            <a:schemeClr val="accent1"/>
+          </a:effectRef>
+          <a:fontRef idx="minor">
+            <a:schemeClr val="lt1"/>
+          </a:fontRef>
+        </p:style>
+        <p:txBody>
+          <a:bodyPr rtlCol="0" anchor="ctr"/>
+          <a:lstStyle/>
+          <a:p>
+            <a:pPr algn="ctr"/>
+          </a:p>
+        </p:txBody>
+      </p:sp>
+      <p:sp>
+        <p:nvSpPr>
+          <p:cNvPr id="9" name="Rectangle 8"/>
+          <p:cNvSpPr/>
+          <p:nvPr/>
+        </p:nvSpPr>
+        <p:spPr>
+          <a:xfrm>
+            <a:off x="320040" y="1353312"/>
+            <a:ext cx="3822191" cy="384048"/>
           </a:xfrm>
           <a:prstGeom prst="rect">
             <a:avLst/>
@@ -15851,6 +15938,1445 @@
       </p:sp>
       <p:sp>
         <p:nvSpPr>
+          <p:cNvPr id="10" name="TextBox 9"/>
+          <p:cNvSpPr txBox="1"/>
+          <p:nvPr/>
+        </p:nvSpPr>
+        <p:spPr>
+          <a:xfrm>
+            <a:off x="429768" y="1408176"/>
+            <a:ext cx="3621023" cy="292608"/>
+          </a:xfrm>
+          <a:prstGeom prst="rect">
+            <a:avLst/>
+          </a:prstGeom>
+          <a:noFill/>
+        </p:spPr>
+        <p:txBody>
+          <a:bodyPr wrap="square">
+            <a:spAutoFit/>
+          </a:bodyPr>
+          <a:lstStyle/>
+          <a:p>
+            <a:pPr algn="l"/>
+            <a:r>
+              <a:rPr sz="1300" b="1" i="0">
+                <a:solidFill>
+                  <a:srgbClr val="0F172A"/>
+                </a:solidFill>
+                <a:latin typeface="Segoe UI"/>
+              </a:rPr>
+              <a:t>🏗  Architecture &amp; Design</a:t>
+            </a:r>
+          </a:p>
+        </p:txBody>
+      </p:sp>
+      <p:sp>
+        <p:nvSpPr>
+          <p:cNvPr id="11" name="TextBox 10"/>
+          <p:cNvSpPr txBox="1"/>
+          <p:nvPr/>
+        </p:nvSpPr>
+        <p:spPr>
+          <a:xfrm>
+            <a:off x="448056" y="1810512"/>
+            <a:ext cx="3584447" cy="1682496"/>
+          </a:xfrm>
+          <a:prstGeom prst="rect">
+            <a:avLst/>
+          </a:prstGeom>
+          <a:noFill/>
+        </p:spPr>
+        <p:txBody>
+          <a:bodyPr wrap="square">
+            <a:spAutoFit/>
+          </a:bodyPr>
+          <a:lstStyle/>
+          <a:p>
+            <a:pPr algn="l"/>
+            <a:r>
+              <a:rPr sz="1200">
+                <a:solidFill>
+                  <a:srgbClr val="CBD5E1"/>
+                </a:solidFill>
+                <a:latin typeface="Segoe UI"/>
+              </a:rPr>
+              <a:t>• Proposed async two-layer pipeline</a:t>
+            </a:r>
+          </a:p>
+          <a:p>
+            <a:pPr algn="l"/>
+            <a:r>
+              <a:rPr sz="1200">
+                <a:solidFill>
+                  <a:srgbClr val="CBD5E1"/>
+                </a:solidFill>
+                <a:latin typeface="Segoe UI"/>
+              </a:rPr>
+              <a:t>• Recommended asyncio.gather() concurrency</a:t>
+            </a:r>
+          </a:p>
+          <a:p>
+            <a:pPr algn="l"/>
+            <a:r>
+              <a:rPr sz="1200">
+                <a:solidFill>
+                  <a:srgbClr val="CBD5E1"/>
+                </a:solidFill>
+                <a:latin typeface="Segoe UI"/>
+              </a:rPr>
+              <a:t>• Designed Pydantic v2 HttpUrl validation</a:t>
+            </a:r>
+          </a:p>
+          <a:p>
+            <a:pPr algn="l"/>
+            <a:r>
+              <a:rPr sz="1200">
+                <a:solidFill>
+                  <a:srgbClr val="CBD5E1"/>
+                </a:solidFill>
+                <a:latin typeface="Segoe UI"/>
+              </a:rPr>
+              <a:t>• Structured monorepo layout</a:t>
+            </a:r>
+          </a:p>
+        </p:txBody>
+      </p:sp>
+      <p:sp>
+        <p:nvSpPr>
+          <p:cNvPr id="12" name="Rectangle 11"/>
+          <p:cNvSpPr/>
+          <p:nvPr/>
+        </p:nvSpPr>
+        <p:spPr>
+          <a:xfrm>
+            <a:off x="4251959" y="1353312"/>
+            <a:ext cx="3822191" cy="2212848"/>
+          </a:xfrm>
+          <a:prstGeom prst="rect">
+            <a:avLst/>
+          </a:prstGeom>
+          <a:solidFill>
+            <a:srgbClr val="1E293B"/>
+          </a:solidFill>
+          <a:ln>
+            <a:noFill/>
+          </a:ln>
+        </p:spPr>
+        <p:style>
+          <a:lnRef idx="1">
+            <a:schemeClr val="accent1"/>
+          </a:lnRef>
+          <a:fillRef idx="3">
+            <a:schemeClr val="accent1"/>
+          </a:fillRef>
+          <a:effectRef idx="2">
+            <a:schemeClr val="accent1"/>
+          </a:effectRef>
+          <a:fontRef idx="minor">
+            <a:schemeClr val="lt1"/>
+          </a:fontRef>
+        </p:style>
+        <p:txBody>
+          <a:bodyPr rtlCol="0" anchor="ctr"/>
+          <a:lstStyle/>
+          <a:p>
+            <a:pPr algn="ctr"/>
+          </a:p>
+        </p:txBody>
+      </p:sp>
+      <p:sp>
+        <p:nvSpPr>
+          <p:cNvPr id="13" name="Rectangle 12"/>
+          <p:cNvSpPr/>
+          <p:nvPr/>
+        </p:nvSpPr>
+        <p:spPr>
+          <a:xfrm>
+            <a:off x="4251959" y="1353312"/>
+            <a:ext cx="3822191" cy="384048"/>
+          </a:xfrm>
+          <a:prstGeom prst="rect">
+            <a:avLst/>
+          </a:prstGeom>
+          <a:solidFill>
+            <a:srgbClr val="38BDF8"/>
+          </a:solidFill>
+          <a:ln>
+            <a:noFill/>
+          </a:ln>
+        </p:spPr>
+        <p:style>
+          <a:lnRef idx="1">
+            <a:schemeClr val="accent1"/>
+          </a:lnRef>
+          <a:fillRef idx="3">
+            <a:schemeClr val="accent1"/>
+          </a:fillRef>
+          <a:effectRef idx="2">
+            <a:schemeClr val="accent1"/>
+          </a:effectRef>
+          <a:fontRef idx="minor">
+            <a:schemeClr val="lt1"/>
+          </a:fontRef>
+        </p:style>
+        <p:txBody>
+          <a:bodyPr rtlCol="0" anchor="ctr"/>
+          <a:lstStyle/>
+          <a:p>
+            <a:pPr algn="ctr"/>
+          </a:p>
+        </p:txBody>
+      </p:sp>
+      <p:sp>
+        <p:nvSpPr>
+          <p:cNvPr id="14" name="TextBox 13"/>
+          <p:cNvSpPr txBox="1"/>
+          <p:nvPr/>
+        </p:nvSpPr>
+        <p:spPr>
+          <a:xfrm>
+            <a:off x="4361687" y="1408176"/>
+            <a:ext cx="3621023" cy="292608"/>
+          </a:xfrm>
+          <a:prstGeom prst="rect">
+            <a:avLst/>
+          </a:prstGeom>
+          <a:noFill/>
+        </p:spPr>
+        <p:txBody>
+          <a:bodyPr wrap="square">
+            <a:spAutoFit/>
+          </a:bodyPr>
+          <a:lstStyle/>
+          <a:p>
+            <a:pPr algn="l"/>
+            <a:r>
+              <a:rPr sz="1300" b="1" i="0">
+                <a:solidFill>
+                  <a:srgbClr val="0F172A"/>
+                </a:solidFill>
+                <a:latin typeface="Segoe UI"/>
+              </a:rPr>
+              <a:t>⚙  Backend Development</a:t>
+            </a:r>
+          </a:p>
+        </p:txBody>
+      </p:sp>
+      <p:sp>
+        <p:nvSpPr>
+          <p:cNvPr id="15" name="TextBox 14"/>
+          <p:cNvSpPr txBox="1"/>
+          <p:nvPr/>
+        </p:nvSpPr>
+        <p:spPr>
+          <a:xfrm>
+            <a:off x="4379975" y="1810512"/>
+            <a:ext cx="3584447" cy="1682496"/>
+          </a:xfrm>
+          <a:prstGeom prst="rect">
+            <a:avLst/>
+          </a:prstGeom>
+          <a:noFill/>
+        </p:spPr>
+        <p:txBody>
+          <a:bodyPr wrap="square">
+            <a:spAutoFit/>
+          </a:bodyPr>
+          <a:lstStyle/>
+          <a:p>
+            <a:pPr algn="l"/>
+            <a:r>
+              <a:rPr sz="1200">
+                <a:solidFill>
+                  <a:srgbClr val="CBD5E1"/>
+                </a:solidFill>
+                <a:latin typeface="Segoe UI"/>
+              </a:rPr>
+              <a:t>• Wrote complete FastAPI main.py</a:t>
+            </a:r>
+          </a:p>
+          <a:p>
+            <a:pPr algn="l"/>
+            <a:r>
+              <a:rPr sz="1200">
+                <a:solidFill>
+                  <a:srgbClr val="CBD5E1"/>
+                </a:solidFill>
+                <a:latin typeface="Segoe UI"/>
+              </a:rPr>
+              <a:t>• LLM prompt engineering (strict JSON)</a:t>
+            </a:r>
+          </a:p>
+          <a:p>
+            <a:pPr algn="l"/>
+            <a:r>
+              <a:rPr sz="1200">
+                <a:solidFill>
+                  <a:srgbClr val="CBD5E1"/>
+                </a:solidFill>
+                <a:latin typeface="Segoe UI"/>
+              </a:rPr>
+              <a:t>• OpenRouter httpx integration</a:t>
+            </a:r>
+          </a:p>
+          <a:p>
+            <a:pPr algn="l"/>
+            <a:r>
+              <a:rPr sz="1200">
+                <a:solidFill>
+                  <a:srgbClr val="CBD5E1"/>
+                </a:solidFill>
+                <a:latin typeface="Segoe UI"/>
+              </a:rPr>
+              <a:t>• Global error handler (no tracebacks)</a:t>
+            </a:r>
+          </a:p>
+        </p:txBody>
+      </p:sp>
+      <p:sp>
+        <p:nvSpPr>
+          <p:cNvPr id="16" name="Rectangle 15"/>
+          <p:cNvSpPr/>
+          <p:nvPr/>
+        </p:nvSpPr>
+        <p:spPr>
+          <a:xfrm>
+            <a:off x="8183878" y="1353312"/>
+            <a:ext cx="3822191" cy="2212848"/>
+          </a:xfrm>
+          <a:prstGeom prst="rect">
+            <a:avLst/>
+          </a:prstGeom>
+          <a:solidFill>
+            <a:srgbClr val="1E293B"/>
+          </a:solidFill>
+          <a:ln>
+            <a:noFill/>
+          </a:ln>
+        </p:spPr>
+        <p:style>
+          <a:lnRef idx="1">
+            <a:schemeClr val="accent1"/>
+          </a:lnRef>
+          <a:fillRef idx="3">
+            <a:schemeClr val="accent1"/>
+          </a:fillRef>
+          <a:effectRef idx="2">
+            <a:schemeClr val="accent1"/>
+          </a:effectRef>
+          <a:fontRef idx="minor">
+            <a:schemeClr val="lt1"/>
+          </a:fontRef>
+        </p:style>
+        <p:txBody>
+          <a:bodyPr rtlCol="0" anchor="ctr"/>
+          <a:lstStyle/>
+          <a:p>
+            <a:pPr algn="ctr"/>
+          </a:p>
+        </p:txBody>
+      </p:sp>
+      <p:sp>
+        <p:nvSpPr>
+          <p:cNvPr id="17" name="Rectangle 16"/>
+          <p:cNvSpPr/>
+          <p:nvPr/>
+        </p:nvSpPr>
+        <p:spPr>
+          <a:xfrm>
+            <a:off x="8183878" y="1353312"/>
+            <a:ext cx="3822191" cy="384048"/>
+          </a:xfrm>
+          <a:prstGeom prst="rect">
+            <a:avLst/>
+          </a:prstGeom>
+          <a:solidFill>
+            <a:srgbClr val="22C55E"/>
+          </a:solidFill>
+          <a:ln>
+            <a:noFill/>
+          </a:ln>
+        </p:spPr>
+        <p:style>
+          <a:lnRef idx="1">
+            <a:schemeClr val="accent1"/>
+          </a:lnRef>
+          <a:fillRef idx="3">
+            <a:schemeClr val="accent1"/>
+          </a:fillRef>
+          <a:effectRef idx="2">
+            <a:schemeClr val="accent1"/>
+          </a:effectRef>
+          <a:fontRef idx="minor">
+            <a:schemeClr val="lt1"/>
+          </a:fontRef>
+        </p:style>
+        <p:txBody>
+          <a:bodyPr rtlCol="0" anchor="ctr"/>
+          <a:lstStyle/>
+          <a:p>
+            <a:pPr algn="ctr"/>
+          </a:p>
+        </p:txBody>
+      </p:sp>
+      <p:sp>
+        <p:nvSpPr>
+          <p:cNvPr id="18" name="TextBox 17"/>
+          <p:cNvSpPr txBox="1"/>
+          <p:nvPr/>
+        </p:nvSpPr>
+        <p:spPr>
+          <a:xfrm>
+            <a:off x="8293606" y="1408176"/>
+            <a:ext cx="3621023" cy="292608"/>
+          </a:xfrm>
+          <a:prstGeom prst="rect">
+            <a:avLst/>
+          </a:prstGeom>
+          <a:noFill/>
+        </p:spPr>
+        <p:txBody>
+          <a:bodyPr wrap="square">
+            <a:spAutoFit/>
+          </a:bodyPr>
+          <a:lstStyle/>
+          <a:p>
+            <a:pPr algn="l"/>
+            <a:r>
+              <a:rPr sz="1300" b="1" i="0">
+                <a:solidFill>
+                  <a:srgbClr val="0F172A"/>
+                </a:solidFill>
+                <a:latin typeface="Segoe UI"/>
+              </a:rPr>
+              <a:t>🔍  Senior Code Review</a:t>
+            </a:r>
+          </a:p>
+        </p:txBody>
+      </p:sp>
+      <p:sp>
+        <p:nvSpPr>
+          <p:cNvPr id="19" name="TextBox 18"/>
+          <p:cNvSpPr txBox="1"/>
+          <p:nvPr/>
+        </p:nvSpPr>
+        <p:spPr>
+          <a:xfrm>
+            <a:off x="8311894" y="1810512"/>
+            <a:ext cx="3584447" cy="1682496"/>
+          </a:xfrm>
+          <a:prstGeom prst="rect">
+            <a:avLst/>
+          </a:prstGeom>
+          <a:noFill/>
+        </p:spPr>
+        <p:txBody>
+          <a:bodyPr wrap="square">
+            <a:spAutoFit/>
+          </a:bodyPr>
+          <a:lstStyle/>
+          <a:p>
+            <a:pPr algn="l"/>
+            <a:r>
+              <a:rPr sz="1200">
+                <a:solidFill>
+                  <a:srgbClr val="CBD5E1"/>
+                </a:solidFill>
+                <a:latin typeface="Segoe UI"/>
+              </a:rPr>
+              <a:t>• Audited ALL files before changes</a:t>
+            </a:r>
+          </a:p>
+          <a:p>
+            <a:pPr algn="l"/>
+            <a:r>
+              <a:rPr sz="1200">
+                <a:solidFill>
+                  <a:srgbClr val="CBD5E1"/>
+                </a:solidFill>
+                <a:latin typeface="Segoe UI"/>
+              </a:rPr>
+              <a:t>• Fixed 15 bugs across backend+frontend</a:t>
+            </a:r>
+          </a:p>
+          <a:p>
+            <a:pPr algn="l"/>
+            <a:r>
+              <a:rPr sz="1200">
+                <a:solidFill>
+                  <a:srgbClr val="CBD5E1"/>
+                </a:solidFill>
+                <a:latin typeface="Segoe UI"/>
+              </a:rPr>
+              <a:t>• Diagnosed root causes, not patches</a:t>
+            </a:r>
+          </a:p>
+          <a:p>
+            <a:pPr algn="l"/>
+            <a:r>
+              <a:rPr sz="1200">
+                <a:solidFill>
+                  <a:srgbClr val="CBD5E1"/>
+                </a:solidFill>
+                <a:latin typeface="Segoe UI"/>
+              </a:rPr>
+              <a:t>• CORS, asyncio, dotenv, model slug</a:t>
+            </a:r>
+          </a:p>
+        </p:txBody>
+      </p:sp>
+      <p:sp>
+        <p:nvSpPr>
+          <p:cNvPr id="20" name="Rectangle 19"/>
+          <p:cNvSpPr/>
+          <p:nvPr/>
+        </p:nvSpPr>
+        <p:spPr>
+          <a:xfrm>
+            <a:off x="320040" y="3675888"/>
+            <a:ext cx="3822191" cy="2212848"/>
+          </a:xfrm>
+          <a:prstGeom prst="rect">
+            <a:avLst/>
+          </a:prstGeom>
+          <a:solidFill>
+            <a:srgbClr val="1E293B"/>
+          </a:solidFill>
+          <a:ln>
+            <a:noFill/>
+          </a:ln>
+        </p:spPr>
+        <p:style>
+          <a:lnRef idx="1">
+            <a:schemeClr val="accent1"/>
+          </a:lnRef>
+          <a:fillRef idx="3">
+            <a:schemeClr val="accent1"/>
+          </a:fillRef>
+          <a:effectRef idx="2">
+            <a:schemeClr val="accent1"/>
+          </a:effectRef>
+          <a:fontRef idx="minor">
+            <a:schemeClr val="lt1"/>
+          </a:fontRef>
+        </p:style>
+        <p:txBody>
+          <a:bodyPr rtlCol="0" anchor="ctr"/>
+          <a:lstStyle/>
+          <a:p>
+            <a:pPr algn="ctr"/>
+          </a:p>
+        </p:txBody>
+      </p:sp>
+      <p:sp>
+        <p:nvSpPr>
+          <p:cNvPr id="21" name="Rectangle 20"/>
+          <p:cNvSpPr/>
+          <p:nvPr/>
+        </p:nvSpPr>
+        <p:spPr>
+          <a:xfrm>
+            <a:off x="320040" y="3675888"/>
+            <a:ext cx="3822191" cy="384048"/>
+          </a:xfrm>
+          <a:prstGeom prst="rect">
+            <a:avLst/>
+          </a:prstGeom>
+          <a:solidFill>
+            <a:srgbClr val="EAB308"/>
+          </a:solidFill>
+          <a:ln>
+            <a:noFill/>
+          </a:ln>
+        </p:spPr>
+        <p:style>
+          <a:lnRef idx="1">
+            <a:schemeClr val="accent1"/>
+          </a:lnRef>
+          <a:fillRef idx="3">
+            <a:schemeClr val="accent1"/>
+          </a:fillRef>
+          <a:effectRef idx="2">
+            <a:schemeClr val="accent1"/>
+          </a:effectRef>
+          <a:fontRef idx="minor">
+            <a:schemeClr val="lt1"/>
+          </a:fontRef>
+        </p:style>
+        <p:txBody>
+          <a:bodyPr rtlCol="0" anchor="ctr"/>
+          <a:lstStyle/>
+          <a:p>
+            <a:pPr algn="ctr"/>
+          </a:p>
+        </p:txBody>
+      </p:sp>
+      <p:sp>
+        <p:nvSpPr>
+          <p:cNvPr id="22" name="TextBox 21"/>
+          <p:cNvSpPr txBox="1"/>
+          <p:nvPr/>
+        </p:nvSpPr>
+        <p:spPr>
+          <a:xfrm>
+            <a:off x="429768" y="3730752"/>
+            <a:ext cx="3621023" cy="292608"/>
+          </a:xfrm>
+          <a:prstGeom prst="rect">
+            <a:avLst/>
+          </a:prstGeom>
+          <a:noFill/>
+        </p:spPr>
+        <p:txBody>
+          <a:bodyPr wrap="square">
+            <a:spAutoFit/>
+          </a:bodyPr>
+          <a:lstStyle/>
+          <a:p>
+            <a:pPr algn="l"/>
+            <a:r>
+              <a:rPr sz="1300" b="1" i="0">
+                <a:solidFill>
+                  <a:srgbClr val="0F172A"/>
+                </a:solidFill>
+                <a:latin typeface="Segoe UI"/>
+              </a:rPr>
+              <a:t>🎨  Frontend Development</a:t>
+            </a:r>
+          </a:p>
+        </p:txBody>
+      </p:sp>
+      <p:sp>
+        <p:nvSpPr>
+          <p:cNvPr id="23" name="TextBox 22"/>
+          <p:cNvSpPr txBox="1"/>
+          <p:nvPr/>
+        </p:nvSpPr>
+        <p:spPr>
+          <a:xfrm>
+            <a:off x="448056" y="4133088"/>
+            <a:ext cx="3584447" cy="1682496"/>
+          </a:xfrm>
+          <a:prstGeom prst="rect">
+            <a:avLst/>
+          </a:prstGeom>
+          <a:noFill/>
+        </p:spPr>
+        <p:txBody>
+          <a:bodyPr wrap="square">
+            <a:spAutoFit/>
+          </a:bodyPr>
+          <a:lstStyle/>
+          <a:p>
+            <a:pPr algn="l"/>
+            <a:r>
+              <a:rPr sz="1200">
+                <a:solidFill>
+                  <a:srgbClr val="CBD5E1"/>
+                </a:solidFill>
+                <a:latin typeface="Segoe UI"/>
+              </a:rPr>
+              <a:t>• Built React 18 + Tailwind dark UI</a:t>
+            </a:r>
+          </a:p>
+          <a:p>
+            <a:pPr algn="l"/>
+            <a:r>
+              <a:rPr sz="1200">
+                <a:solidFill>
+                  <a:srgbClr val="CBD5E1"/>
+                </a:solidFill>
+                <a:latin typeface="Segoe UI"/>
+              </a:rPr>
+              <a:t>• Animated RiskMeter + RiskBadge</a:t>
+            </a:r>
+          </a:p>
+          <a:p>
+            <a:pPr algn="l"/>
+            <a:r>
+              <a:rPr sz="1200">
+                <a:solidFill>
+                  <a:srgbClr val="CBD5E1"/>
+                </a:solidFill>
+                <a:latin typeface="Segoe UI"/>
+              </a:rPr>
+              <a:t>• AbortController request cancellation</a:t>
+            </a:r>
+          </a:p>
+          <a:p>
+            <a:pPr algn="l"/>
+            <a:r>
+              <a:rPr sz="1200">
+                <a:solidFill>
+                  <a:srgbClr val="CBD5E1"/>
+                </a:solidFill>
+                <a:latin typeface="Segoe UI"/>
+              </a:rPr>
+              <a:t>• Full ARIA accessibility attributes</a:t>
+            </a:r>
+          </a:p>
+        </p:txBody>
+      </p:sp>
+      <p:sp>
+        <p:nvSpPr>
+          <p:cNvPr id="24" name="Rectangle 23"/>
+          <p:cNvSpPr/>
+          <p:nvPr/>
+        </p:nvSpPr>
+        <p:spPr>
+          <a:xfrm>
+            <a:off x="4251959" y="3675888"/>
+            <a:ext cx="3822191" cy="2212848"/>
+          </a:xfrm>
+          <a:prstGeom prst="rect">
+            <a:avLst/>
+          </a:prstGeom>
+          <a:solidFill>
+            <a:srgbClr val="1E293B"/>
+          </a:solidFill>
+          <a:ln>
+            <a:noFill/>
+          </a:ln>
+        </p:spPr>
+        <p:style>
+          <a:lnRef idx="1">
+            <a:schemeClr val="accent1"/>
+          </a:lnRef>
+          <a:fillRef idx="3">
+            <a:schemeClr val="accent1"/>
+          </a:fillRef>
+          <a:effectRef idx="2">
+            <a:schemeClr val="accent1"/>
+          </a:effectRef>
+          <a:fontRef idx="minor">
+            <a:schemeClr val="lt1"/>
+          </a:fontRef>
+        </p:style>
+        <p:txBody>
+          <a:bodyPr rtlCol="0" anchor="ctr"/>
+          <a:lstStyle/>
+          <a:p>
+            <a:pPr algn="ctr"/>
+          </a:p>
+        </p:txBody>
+      </p:sp>
+      <p:sp>
+        <p:nvSpPr>
+          <p:cNvPr id="25" name="Rectangle 24"/>
+          <p:cNvSpPr/>
+          <p:nvPr/>
+        </p:nvSpPr>
+        <p:spPr>
+          <a:xfrm>
+            <a:off x="4251959" y="3675888"/>
+            <a:ext cx="3822191" cy="384048"/>
+          </a:xfrm>
+          <a:prstGeom prst="rect">
+            <a:avLst/>
+          </a:prstGeom>
+          <a:solidFill>
+            <a:srgbClr val="F97316"/>
+          </a:solidFill>
+          <a:ln>
+            <a:noFill/>
+          </a:ln>
+        </p:spPr>
+        <p:style>
+          <a:lnRef idx="1">
+            <a:schemeClr val="accent1"/>
+          </a:lnRef>
+          <a:fillRef idx="3">
+            <a:schemeClr val="accent1"/>
+          </a:fillRef>
+          <a:effectRef idx="2">
+            <a:schemeClr val="accent1"/>
+          </a:effectRef>
+          <a:fontRef idx="minor">
+            <a:schemeClr val="lt1"/>
+          </a:fontRef>
+        </p:style>
+        <p:txBody>
+          <a:bodyPr rtlCol="0" anchor="ctr"/>
+          <a:lstStyle/>
+          <a:p>
+            <a:pPr algn="ctr"/>
+          </a:p>
+        </p:txBody>
+      </p:sp>
+      <p:sp>
+        <p:nvSpPr>
+          <p:cNvPr id="26" name="TextBox 25"/>
+          <p:cNvSpPr txBox="1"/>
+          <p:nvPr/>
+        </p:nvSpPr>
+        <p:spPr>
+          <a:xfrm>
+            <a:off x="4361687" y="3730752"/>
+            <a:ext cx="3621023" cy="292608"/>
+          </a:xfrm>
+          <a:prstGeom prst="rect">
+            <a:avLst/>
+          </a:prstGeom>
+          <a:noFill/>
+        </p:spPr>
+        <p:txBody>
+          <a:bodyPr wrap="square">
+            <a:spAutoFit/>
+          </a:bodyPr>
+          <a:lstStyle/>
+          <a:p>
+            <a:pPr algn="l"/>
+            <a:r>
+              <a:rPr sz="1300" b="1" i="0">
+                <a:solidFill>
+                  <a:srgbClr val="0F172A"/>
+                </a:solidFill>
+                <a:latin typeface="Segoe UI"/>
+              </a:rPr>
+              <a:t>🚀  DevOps &amp; Deployment</a:t>
+            </a:r>
+          </a:p>
+        </p:txBody>
+      </p:sp>
+      <p:sp>
+        <p:nvSpPr>
+          <p:cNvPr id="27" name="TextBox 26"/>
+          <p:cNvSpPr txBox="1"/>
+          <p:nvPr/>
+        </p:nvSpPr>
+        <p:spPr>
+          <a:xfrm>
+            <a:off x="4379975" y="4133088"/>
+            <a:ext cx="3584447" cy="1682496"/>
+          </a:xfrm>
+          <a:prstGeom prst="rect">
+            <a:avLst/>
+          </a:prstGeom>
+          <a:noFill/>
+        </p:spPr>
+        <p:txBody>
+          <a:bodyPr wrap="square">
+            <a:spAutoFit/>
+          </a:bodyPr>
+          <a:lstStyle/>
+          <a:p>
+            <a:pPr algn="l"/>
+            <a:r>
+              <a:rPr sz="1200">
+                <a:solidFill>
+                  <a:srgbClr val="CBD5E1"/>
+                </a:solidFill>
+                <a:latin typeface="Segoe UI"/>
+              </a:rPr>
+              <a:t>• Generated render.yaml (IaC)</a:t>
+            </a:r>
+          </a:p>
+          <a:p>
+            <a:pPr algn="l"/>
+            <a:r>
+              <a:rPr sz="1200">
+                <a:solidFill>
+                  <a:srgbClr val="CBD5E1"/>
+                </a:solidFill>
+                <a:latin typeface="Segoe UI"/>
+              </a:rPr>
+              <a:t>• vercel.json (SPA rewrite + security headers)</a:t>
+            </a:r>
+          </a:p>
+          <a:p>
+            <a:pPr algn="l"/>
+            <a:r>
+              <a:rPr sz="1200">
+                <a:solidFill>
+                  <a:srgbClr val="CBD5E1"/>
+                </a:solidFill>
+                <a:latin typeface="Segoe UI"/>
+              </a:rPr>
+              <a:t>• DEPLOYMENT.md (6-step guide)</a:t>
+            </a:r>
+          </a:p>
+          <a:p>
+            <a:pPr algn="l"/>
+            <a:r>
+              <a:rPr sz="1200">
+                <a:solidFill>
+                  <a:srgbClr val="CBD5E1"/>
+                </a:solidFill>
+                <a:latin typeface="Segoe UI"/>
+              </a:rPr>
+              <a:t>• Git push + CI/CD pipeline setup</a:t>
+            </a:r>
+          </a:p>
+        </p:txBody>
+      </p:sp>
+      <p:sp>
+        <p:nvSpPr>
+          <p:cNvPr id="28" name="Rectangle 27"/>
+          <p:cNvSpPr/>
+          <p:nvPr/>
+        </p:nvSpPr>
+        <p:spPr>
+          <a:xfrm>
+            <a:off x="8183878" y="3675888"/>
+            <a:ext cx="3822191" cy="2212848"/>
+          </a:xfrm>
+          <a:prstGeom prst="rect">
+            <a:avLst/>
+          </a:prstGeom>
+          <a:solidFill>
+            <a:srgbClr val="1E293B"/>
+          </a:solidFill>
+          <a:ln>
+            <a:noFill/>
+          </a:ln>
+        </p:spPr>
+        <p:style>
+          <a:lnRef idx="1">
+            <a:schemeClr val="accent1"/>
+          </a:lnRef>
+          <a:fillRef idx="3">
+            <a:schemeClr val="accent1"/>
+          </a:fillRef>
+          <a:effectRef idx="2">
+            <a:schemeClr val="accent1"/>
+          </a:effectRef>
+          <a:fontRef idx="minor">
+            <a:schemeClr val="lt1"/>
+          </a:fontRef>
+        </p:style>
+        <p:txBody>
+          <a:bodyPr rtlCol="0" anchor="ctr"/>
+          <a:lstStyle/>
+          <a:p>
+            <a:pPr algn="ctr"/>
+          </a:p>
+        </p:txBody>
+      </p:sp>
+      <p:sp>
+        <p:nvSpPr>
+          <p:cNvPr id="29" name="Rectangle 28"/>
+          <p:cNvSpPr/>
+          <p:nvPr/>
+        </p:nvSpPr>
+        <p:spPr>
+          <a:xfrm>
+            <a:off x="8183878" y="3675888"/>
+            <a:ext cx="3822191" cy="384048"/>
+          </a:xfrm>
+          <a:prstGeom prst="rect">
+            <a:avLst/>
+          </a:prstGeom>
+          <a:solidFill>
+            <a:srgbClr val="A5B4FC"/>
+          </a:solidFill>
+          <a:ln>
+            <a:noFill/>
+          </a:ln>
+        </p:spPr>
+        <p:style>
+          <a:lnRef idx="1">
+            <a:schemeClr val="accent1"/>
+          </a:lnRef>
+          <a:fillRef idx="3">
+            <a:schemeClr val="accent1"/>
+          </a:fillRef>
+          <a:effectRef idx="2">
+            <a:schemeClr val="accent1"/>
+          </a:effectRef>
+          <a:fontRef idx="minor">
+            <a:schemeClr val="lt1"/>
+          </a:fontRef>
+        </p:style>
+        <p:txBody>
+          <a:bodyPr rtlCol="0" anchor="ctr"/>
+          <a:lstStyle/>
+          <a:p>
+            <a:pPr algn="ctr"/>
+          </a:p>
+        </p:txBody>
+      </p:sp>
+      <p:sp>
+        <p:nvSpPr>
+          <p:cNvPr id="30" name="TextBox 29"/>
+          <p:cNvSpPr txBox="1"/>
+          <p:nvPr/>
+        </p:nvSpPr>
+        <p:spPr>
+          <a:xfrm>
+            <a:off x="8293606" y="3730752"/>
+            <a:ext cx="3621023" cy="292608"/>
+          </a:xfrm>
+          <a:prstGeom prst="rect">
+            <a:avLst/>
+          </a:prstGeom>
+          <a:noFill/>
+        </p:spPr>
+        <p:txBody>
+          <a:bodyPr wrap="square">
+            <a:spAutoFit/>
+          </a:bodyPr>
+          <a:lstStyle/>
+          <a:p>
+            <a:pPr algn="l"/>
+            <a:r>
+              <a:rPr sz="1300" b="1" i="0">
+                <a:solidFill>
+                  <a:srgbClr val="0F172A"/>
+                </a:solidFill>
+                <a:latin typeface="Segoe UI"/>
+              </a:rPr>
+              <a:t>📄  All Documentation</a:t>
+            </a:r>
+          </a:p>
+        </p:txBody>
+      </p:sp>
+      <p:sp>
+        <p:nvSpPr>
+          <p:cNvPr id="31" name="TextBox 30"/>
+          <p:cNvSpPr txBox="1"/>
+          <p:nvPr/>
+        </p:nvSpPr>
+        <p:spPr>
+          <a:xfrm>
+            <a:off x="8311894" y="4133088"/>
+            <a:ext cx="3584447" cy="1682496"/>
+          </a:xfrm>
+          <a:prstGeom prst="rect">
+            <a:avLst/>
+          </a:prstGeom>
+          <a:noFill/>
+        </p:spPr>
+        <p:txBody>
+          <a:bodyPr wrap="square">
+            <a:spAutoFit/>
+          </a:bodyPr>
+          <a:lstStyle/>
+          <a:p>
+            <a:pPr algn="l"/>
+            <a:r>
+              <a:rPr sz="1200">
+                <a:solidFill>
+                  <a:srgbClr val="CBD5E1"/>
+                </a:solidFill>
+                <a:latin typeface="Segoe UI"/>
+              </a:rPr>
+              <a:t>• README.md — 47 KB, 24 sections</a:t>
+            </a:r>
+          </a:p>
+          <a:p>
+            <a:pPr algn="l"/>
+            <a:r>
+              <a:rPr sz="1200">
+                <a:solidFill>
+                  <a:srgbClr val="CBD5E1"/>
+                </a:solidFill>
+                <a:latin typeface="Segoe UI"/>
+              </a:rPr>
+              <a:t>• IBM_BOB_USAGE.md for judges</a:t>
+            </a:r>
+          </a:p>
+          <a:p>
+            <a:pPr algn="l"/>
+            <a:r>
+              <a:rPr sz="1200">
+                <a:solidFill>
+                  <a:srgbClr val="CBD5E1"/>
+                </a:solidFill>
+                <a:latin typeface="Segoe UI"/>
+              </a:rPr>
+              <a:t>• SUBMISSION_ANSWERS.md</a:t>
+            </a:r>
+          </a:p>
+          <a:p>
+            <a:pPr algn="l"/>
+            <a:r>
+              <a:rPr sz="1200">
+                <a:solidFill>
+                  <a:srgbClr val="CBD5E1"/>
+                </a:solidFill>
+                <a:latin typeface="Segoe UI"/>
+              </a:rPr>
+              <a:t>• This PPT — auto-generated via python-pptx</a:t>
+            </a:r>
+          </a:p>
+        </p:txBody>
+      </p:sp>
+      <p:sp>
+        <p:nvSpPr>
+          <p:cNvPr id="32" name="Rectangle 31"/>
+          <p:cNvSpPr/>
+          <p:nvPr/>
+        </p:nvSpPr>
+        <p:spPr>
+          <a:xfrm>
+            <a:off x="0" y="6199632"/>
+            <a:ext cx="12188952" cy="566928"/>
+          </a:xfrm>
+          <a:prstGeom prst="rect">
+            <a:avLst/>
+          </a:prstGeom>
+          <a:solidFill>
+            <a:srgbClr val="1A1F4B"/>
+          </a:solidFill>
+          <a:ln>
+            <a:noFill/>
+          </a:ln>
+        </p:spPr>
+        <p:style>
+          <a:lnRef idx="1">
+            <a:schemeClr val="accent1"/>
+          </a:lnRef>
+          <a:fillRef idx="3">
+            <a:schemeClr val="accent1"/>
+          </a:fillRef>
+          <a:effectRef idx="2">
+            <a:schemeClr val="accent1"/>
+          </a:effectRef>
+          <a:fontRef idx="minor">
+            <a:schemeClr val="lt1"/>
+          </a:fontRef>
+        </p:style>
+        <p:txBody>
+          <a:bodyPr rtlCol="0" anchor="ctr"/>
+          <a:lstStyle/>
+          <a:p>
+            <a:pPr algn="ctr"/>
+          </a:p>
+        </p:txBody>
+      </p:sp>
+      <p:sp>
+        <p:nvSpPr>
+          <p:cNvPr id="33" name="TextBox 32"/>
+          <p:cNvSpPr txBox="1"/>
+          <p:nvPr/>
+        </p:nvSpPr>
+        <p:spPr>
+          <a:xfrm>
+            <a:off x="457200" y="6236208"/>
+            <a:ext cx="11247120" cy="475488"/>
+          </a:xfrm>
+          <a:prstGeom prst="rect">
+            <a:avLst/>
+          </a:prstGeom>
+          <a:noFill/>
+        </p:spPr>
+        <p:txBody>
+          <a:bodyPr wrap="square">
+            <a:spAutoFit/>
+          </a:bodyPr>
+          <a:lstStyle/>
+          <a:p>
+            <a:pPr algn="ctr"/>
+            <a:r>
+              <a:rPr sz="1250" b="0" i="1">
+                <a:solidFill>
+                  <a:srgbClr val="38BDF8"/>
+                </a:solidFill>
+                <a:latin typeface="Segoe UI"/>
+              </a:rPr>
+              <a:t>"Every file in this repository was designed, written, reviewed &amp; deployed with IBM Bob as the primary AI engineering partner."</a:t>
+            </a:r>
+          </a:p>
+        </p:txBody>
+      </p:sp>
+      <p:sp>
+        <p:nvSpPr>
+          <p:cNvPr id="34" name="TextBox 33"/>
+          <p:cNvSpPr txBox="1"/>
+          <p:nvPr/>
+        </p:nvSpPr>
+        <p:spPr>
+          <a:xfrm>
+            <a:off x="10972800" y="6510528"/>
+            <a:ext cx="1097280" cy="274320"/>
+          </a:xfrm>
+          <a:prstGeom prst="rect">
+            <a:avLst/>
+          </a:prstGeom>
+          <a:noFill/>
+        </p:spPr>
+        <p:txBody>
+          <a:bodyPr wrap="square">
+            <a:spAutoFit/>
+          </a:bodyPr>
+          <a:lstStyle/>
+          <a:p>
+            <a:pPr algn="r"/>
+            <a:r>
+              <a:rPr sz="1000" b="0" i="0">
+                <a:solidFill>
+                  <a:srgbClr val="94A3B8"/>
+                </a:solidFill>
+                <a:latin typeface="Segoe UI"/>
+              </a:rPr>
+              <a:t>20 / 21</a:t>
+            </a:r>
+          </a:p>
+        </p:txBody>
+      </p:sp>
+    </p:spTree>
+  </p:cSld>
+  <p:clrMapOvr>
+    <a:masterClrMapping/>
+  </p:clrMapOvr>
+</p:sld>
+</file>
+
+<file path=ppt/slides/slide21.xml><?xml version="1.0" encoding="utf-8"?>
+<p:sld xmlns:a="http://schemas.openxmlformats.org/drawingml/2006/main" xmlns:p="http://schemas.openxmlformats.org/presentationml/2006/main" xmlns:r="http://schemas.openxmlformats.org/officeDocument/2006/relationships">
+  <p:cSld>
+    <p:bg>
+      <p:bgPr>
+        <a:solidFill>
+          <a:srgbClr val="0F172A"/>
+        </a:solidFill>
+        <a:effectLst/>
+      </p:bgPr>
+    </p:bg>
+    <p:spTree>
+      <p:nvGrpSpPr>
+        <p:cNvPr id="1" name=""/>
+        <p:cNvGrpSpPr/>
+        <p:nvPr/>
+      </p:nvGrpSpPr>
+      <p:grpSpPr/>
+      <p:sp>
+        <p:nvSpPr>
+          <p:cNvPr id="2" name="Rectangle 1"/>
+          <p:cNvSpPr/>
+          <p:nvPr/>
+        </p:nvSpPr>
+        <p:spPr>
+          <a:xfrm>
+            <a:off x="0" y="0"/>
+            <a:ext cx="12188952" cy="109728"/>
+          </a:xfrm>
+          <a:prstGeom prst="rect">
+            <a:avLst/>
+          </a:prstGeom>
+          <a:solidFill>
+            <a:srgbClr val="6366F1"/>
+          </a:solidFill>
+          <a:ln>
+            <a:noFill/>
+          </a:ln>
+        </p:spPr>
+        <p:style>
+          <a:lnRef idx="1">
+            <a:schemeClr val="accent1"/>
+          </a:lnRef>
+          <a:fillRef idx="3">
+            <a:schemeClr val="accent1"/>
+          </a:fillRef>
+          <a:effectRef idx="2">
+            <a:schemeClr val="accent1"/>
+          </a:effectRef>
+          <a:fontRef idx="minor">
+            <a:schemeClr val="lt1"/>
+          </a:fontRef>
+        </p:style>
+        <p:txBody>
+          <a:bodyPr rtlCol="0" anchor="ctr"/>
+          <a:lstStyle/>
+          <a:p>
+            <a:pPr algn="ctr"/>
+          </a:p>
+        </p:txBody>
+      </p:sp>
+      <p:sp>
+        <p:nvSpPr>
+          <p:cNvPr id="3" name="Rectangle 2"/>
+          <p:cNvSpPr/>
+          <p:nvPr/>
+        </p:nvSpPr>
+        <p:spPr>
+          <a:xfrm>
+            <a:off x="0" y="6748272"/>
+            <a:ext cx="12188952" cy="109728"/>
+          </a:xfrm>
+          <a:prstGeom prst="rect">
+            <a:avLst/>
+          </a:prstGeom>
+          <a:solidFill>
+            <a:srgbClr val="6366F1"/>
+          </a:solidFill>
+          <a:ln>
+            <a:noFill/>
+          </a:ln>
+        </p:spPr>
+        <p:style>
+          <a:lnRef idx="1">
+            <a:schemeClr val="accent1"/>
+          </a:lnRef>
+          <a:fillRef idx="3">
+            <a:schemeClr val="accent1"/>
+          </a:fillRef>
+          <a:effectRef idx="2">
+            <a:schemeClr val="accent1"/>
+          </a:effectRef>
+          <a:fontRef idx="minor">
+            <a:schemeClr val="lt1"/>
+          </a:fontRef>
+        </p:style>
+        <p:txBody>
+          <a:bodyPr rtlCol="0" anchor="ctr"/>
+          <a:lstStyle/>
+          <a:p>
+            <a:pPr algn="ctr"/>
+          </a:p>
+        </p:txBody>
+      </p:sp>
+      <p:sp>
+        <p:nvSpPr>
+          <p:cNvPr id="4" name="TextBox 3"/>
+          <p:cNvSpPr txBox="1"/>
+          <p:nvPr/>
+        </p:nvSpPr>
+        <p:spPr>
+          <a:xfrm>
+            <a:off x="5029200" y="640080"/>
+            <a:ext cx="2103120" cy="1920240"/>
+          </a:xfrm>
+          <a:prstGeom prst="rect">
+            <a:avLst/>
+          </a:prstGeom>
+          <a:noFill/>
+        </p:spPr>
+        <p:txBody>
+          <a:bodyPr wrap="square">
+            <a:spAutoFit/>
+          </a:bodyPr>
+          <a:lstStyle/>
+          <a:p>
+            <a:pPr algn="ctr"/>
+            <a:r>
+              <a:rPr sz="9000" b="0" i="0">
+                <a:solidFill>
+                  <a:srgbClr val="6366F1"/>
+                </a:solidFill>
+                <a:latin typeface="Segoe UI"/>
+              </a:rPr>
+              <a:t>🛡</a:t>
+            </a:r>
+          </a:p>
+        </p:txBody>
+      </p:sp>
+      <p:sp>
+        <p:nvSpPr>
+          <p:cNvPr id="5" name="TextBox 4"/>
+          <p:cNvSpPr txBox="1"/>
+          <p:nvPr/>
+        </p:nvSpPr>
+        <p:spPr>
+          <a:xfrm>
+            <a:off x="914400" y="2606040"/>
+            <a:ext cx="10332720" cy="1143000"/>
+          </a:xfrm>
+          <a:prstGeom prst="rect">
+            <a:avLst/>
+          </a:prstGeom>
+          <a:noFill/>
+        </p:spPr>
+        <p:txBody>
+          <a:bodyPr wrap="square">
+            <a:spAutoFit/>
+          </a:bodyPr>
+          <a:lstStyle/>
+          <a:p>
+            <a:pPr algn="ctr"/>
+            <a:r>
+              <a:rPr sz="6200" b="1" i="0">
+                <a:solidFill>
+                  <a:srgbClr val="FFFFFF"/>
+                </a:solidFill>
+                <a:latin typeface="Segoe UI"/>
+              </a:rPr>
+              <a:t>Thank You</a:t>
+            </a:r>
+          </a:p>
+        </p:txBody>
+      </p:sp>
+      <p:sp>
+        <p:nvSpPr>
+          <p:cNvPr id="6" name="TextBox 5"/>
+          <p:cNvSpPr txBox="1"/>
+          <p:nvPr/>
+        </p:nvSpPr>
+        <p:spPr>
+          <a:xfrm>
+            <a:off x="914400" y="3730752"/>
+            <a:ext cx="10332720" cy="594360"/>
+          </a:xfrm>
+          <a:prstGeom prst="rect">
+            <a:avLst/>
+          </a:prstGeom>
+          <a:noFill/>
+        </p:spPr>
+        <p:txBody>
+          <a:bodyPr wrap="square">
+            <a:spAutoFit/>
+          </a:bodyPr>
+          <a:lstStyle/>
+          <a:p>
+            <a:pPr algn="ctr"/>
+            <a:r>
+              <a:rPr sz="2500" b="0" i="0">
+                <a:solidFill>
+                  <a:srgbClr val="38BDF8"/>
+                </a:solidFill>
+                <a:latin typeface="Segoe UI"/>
+              </a:rPr>
+              <a:t>Questions &amp; Discussion</a:t>
+            </a:r>
+          </a:p>
+        </p:txBody>
+      </p:sp>
+      <p:sp>
+        <p:nvSpPr>
+          <p:cNvPr id="7" name="Rectangle 6"/>
+          <p:cNvSpPr/>
+          <p:nvPr/>
+        </p:nvSpPr>
+        <p:spPr>
+          <a:xfrm>
+            <a:off x="4114800" y="4434840"/>
+            <a:ext cx="3931920" cy="45720"/>
+          </a:xfrm>
+          <a:prstGeom prst="rect">
+            <a:avLst/>
+          </a:prstGeom>
+          <a:solidFill>
+            <a:srgbClr val="6366F1"/>
+          </a:solidFill>
+          <a:ln>
+            <a:noFill/>
+          </a:ln>
+        </p:spPr>
+        <p:style>
+          <a:lnRef idx="1">
+            <a:schemeClr val="accent1"/>
+          </a:lnRef>
+          <a:fillRef idx="3">
+            <a:schemeClr val="accent1"/>
+          </a:fillRef>
+          <a:effectRef idx="2">
+            <a:schemeClr val="accent1"/>
+          </a:effectRef>
+          <a:fontRef idx="minor">
+            <a:schemeClr val="lt1"/>
+          </a:fontRef>
+        </p:style>
+        <p:txBody>
+          <a:bodyPr rtlCol="0" anchor="ctr"/>
+          <a:lstStyle/>
+          <a:p>
+            <a:pPr algn="ctr"/>
+          </a:p>
+        </p:txBody>
+      </p:sp>
+      <p:sp>
+        <p:nvSpPr>
           <p:cNvPr id="8" name="TextBox 7"/>
           <p:cNvSpPr txBox="1"/>
           <p:nvPr/>
@@ -16019,7 +17545,7 @@
                 </a:solidFill>
                 <a:latin typeface="Segoe UI"/>
               </a:rPr>
-              <a:t>20 / 20</a:t>
+              <a:t>21 / 21</a:t>
             </a:r>
           </a:p>
         </p:txBody>

</xml_diff>